<commit_message>
Update 역사 퀴즈 assets and add ZIP slides
Co-Authored-By: Claude Opus 4.6 (1M context) <noreply@anthropic.com>
</commit_message>
<xml_diff>
--- a/public/downloads/games/history-quiz/rules.pptx
+++ b/public/downloads/games/history-quiz/rules.pptx
@@ -55,16 +55,12 @@
   <p:notesSz cx="6858000" cy="9144000"/>
   <p:embeddedFontLst>
     <p:embeddedFont>
-      <p:font typeface="Jua" charset="1" panose="00000000000000000000"/>
+      <p:font typeface="무궁화 고딕" charset="1" panose="02020603020101020101"/>
       <p:regular r:id="rId51"/>
     </p:embeddedFont>
     <p:embeddedFont>
-      <p:font typeface="TDTD갬성명조" charset="1" panose="02000503000000000000"/>
+      <p:font typeface="무궁화 고딕 Bold" charset="1" panose="02020603020101020101"/>
       <p:regular r:id="rId52"/>
-    </p:embeddedFont>
-    <p:embeddedFont>
-      <p:font typeface="TDTD가온" charset="1" panose="02000503000000000000"/>
-      <p:regular r:id="rId53"/>
     </p:embeddedFont>
   </p:embeddedFontLst>
   <p:defaultTextStyle>
@@ -3182,8 +3178,8 @@
         </p:nvSpPr>
         <p:spPr>
           <a:xfrm rot="0">
-            <a:off x="1028700" y="3892867"/>
-            <a:ext cx="15555091" cy="2200275"/>
+            <a:off x="1028700" y="4178617"/>
+            <a:ext cx="15555091" cy="1914525"/>
           </a:xfrm>
           <a:prstGeom prst="rect">
             <a:avLst/>
@@ -3205,10 +3201,10 @@
                 <a:solidFill>
                   <a:srgbClr val="FFFAEF"/>
                 </a:solidFill>
-                <a:latin typeface="Jua"/>
-                <a:ea typeface="Jua"/>
-                <a:cs typeface="Jua"/>
-                <a:sym typeface="Jua"/>
+                <a:latin typeface="무궁화 고딕"/>
+                <a:ea typeface="무궁화 고딕"/>
+                <a:cs typeface="무궁화 고딕"/>
+                <a:sym typeface="무궁화 고딕"/>
               </a:rPr>
               <a:t>역사 퀴즈</a:t>
             </a:r>
@@ -3223,8 +3219,8 @@
         </p:nvSpPr>
         <p:spPr>
           <a:xfrm rot="0">
-            <a:off x="15264803" y="9812655"/>
-            <a:ext cx="2637975" cy="474345"/>
+            <a:off x="14743435" y="9822180"/>
+            <a:ext cx="3159344" cy="464820"/>
           </a:xfrm>
           <a:prstGeom prst="rect">
             <a:avLst/>
@@ -3249,10 +3245,10 @@
                 <a:solidFill>
                   <a:srgbClr val="FFFFFF"/>
                 </a:solidFill>
-                <a:latin typeface="TDTD갬성명조"/>
-                <a:ea typeface="TDTD갬성명조"/>
-                <a:cs typeface="TDTD갬성명조"/>
-                <a:sym typeface="TDTD갬성명조"/>
+                <a:latin typeface="무궁화 고딕"/>
+                <a:ea typeface="무궁화 고딕"/>
+                <a:cs typeface="무궁화 고딕"/>
+                <a:sym typeface="무궁화 고딕"/>
               </a:rPr>
               <a:t>ⓒ 2026. Sunday Play</a:t>
             </a:r>
@@ -3349,8 +3345,8 @@
         </p:nvSpPr>
         <p:spPr>
           <a:xfrm rot="0">
-            <a:off x="2717556" y="3933825"/>
-            <a:ext cx="12852888" cy="2124075"/>
+            <a:off x="2717556" y="4219575"/>
+            <a:ext cx="12852888" cy="1838325"/>
           </a:xfrm>
           <a:prstGeom prst="rect">
             <a:avLst/>
@@ -3372,10 +3368,10 @@
                 <a:solidFill>
                   <a:srgbClr val="000000"/>
                 </a:solidFill>
-                <a:latin typeface="Jua"/>
-                <a:ea typeface="Jua"/>
-                <a:cs typeface="Jua"/>
-                <a:sym typeface="Jua"/>
+                <a:latin typeface="무궁화 고딕"/>
+                <a:ea typeface="무궁화 고딕"/>
+                <a:cs typeface="무궁화 고딕"/>
+                <a:sym typeface="무궁화 고딕"/>
               </a:rPr>
               <a:t>단군</a:t>
             </a:r>
@@ -3472,8 +3468,8 @@
         </p:nvSpPr>
         <p:spPr>
           <a:xfrm rot="0">
-            <a:off x="1135011" y="3190875"/>
-            <a:ext cx="16017978" cy="3629025"/>
+            <a:off x="1135011" y="3457575"/>
+            <a:ext cx="16017978" cy="3362325"/>
           </a:xfrm>
           <a:prstGeom prst="rect">
             <a:avLst/>
@@ -3495,10 +3491,10 @@
                 <a:solidFill>
                   <a:srgbClr val="000000"/>
                 </a:solidFill>
-                <a:latin typeface="Jua"/>
-                <a:ea typeface="Jua"/>
-                <a:cs typeface="Jua"/>
-                <a:sym typeface="Jua"/>
+                <a:latin typeface="무궁화 고딕"/>
+                <a:ea typeface="무궁화 고딕"/>
+                <a:cs typeface="무궁화 고딕"/>
+                <a:sym typeface="무궁화 고딕"/>
               </a:rPr>
               <a:t>임진왜란이 일어난 해는</a:t>
             </a:r>
@@ -3514,10 +3510,10 @@
                 <a:solidFill>
                   <a:srgbClr val="000000"/>
                 </a:solidFill>
-                <a:latin typeface="Jua"/>
-                <a:ea typeface="Jua"/>
-                <a:cs typeface="Jua"/>
-                <a:sym typeface="Jua"/>
+                <a:latin typeface="무궁화 고딕"/>
+                <a:ea typeface="무궁화 고딕"/>
+                <a:cs typeface="무궁화 고딕"/>
+                <a:sym typeface="무궁화 고딕"/>
               </a:rPr>
               <a:t>언제일까요?</a:t>
             </a:r>
@@ -3614,8 +3610,8 @@
         </p:nvSpPr>
         <p:spPr>
           <a:xfrm rot="0">
-            <a:off x="2717556" y="3933825"/>
-            <a:ext cx="12852888" cy="2124075"/>
+            <a:off x="2717556" y="4219575"/>
+            <a:ext cx="12852888" cy="1838325"/>
           </a:xfrm>
           <a:prstGeom prst="rect">
             <a:avLst/>
@@ -3637,10 +3633,10 @@
                 <a:solidFill>
                   <a:srgbClr val="000000"/>
                 </a:solidFill>
-                <a:latin typeface="Jua"/>
-                <a:ea typeface="Jua"/>
-                <a:cs typeface="Jua"/>
-                <a:sym typeface="Jua"/>
+                <a:latin typeface="무궁화 고딕"/>
+                <a:ea typeface="무궁화 고딕"/>
+                <a:cs typeface="무궁화 고딕"/>
+                <a:sym typeface="무궁화 고딕"/>
               </a:rPr>
               <a:t>1592년</a:t>
             </a:r>
@@ -3737,8 +3733,8 @@
         </p:nvSpPr>
         <p:spPr>
           <a:xfrm rot="0">
-            <a:off x="1135011" y="3190875"/>
-            <a:ext cx="16017978" cy="3629025"/>
+            <a:off x="1135011" y="3457575"/>
+            <a:ext cx="16017978" cy="3362325"/>
           </a:xfrm>
           <a:prstGeom prst="rect">
             <a:avLst/>
@@ -3760,10 +3756,10 @@
                 <a:solidFill>
                   <a:srgbClr val="000000"/>
                 </a:solidFill>
-                <a:latin typeface="Jua"/>
-                <a:ea typeface="Jua"/>
-                <a:cs typeface="Jua"/>
-                <a:sym typeface="Jua"/>
+                <a:latin typeface="무궁화 고딕"/>
+                <a:ea typeface="무궁화 고딕"/>
+                <a:cs typeface="무궁화 고딕"/>
+                <a:sym typeface="무궁화 고딕"/>
               </a:rPr>
               <a:t>광개토대왕이 다스린 나라는</a:t>
             </a:r>
@@ -3779,10 +3775,10 @@
                 <a:solidFill>
                   <a:srgbClr val="000000"/>
                 </a:solidFill>
-                <a:latin typeface="Jua"/>
-                <a:ea typeface="Jua"/>
-                <a:cs typeface="Jua"/>
-                <a:sym typeface="Jua"/>
+                <a:latin typeface="무궁화 고딕"/>
+                <a:ea typeface="무궁화 고딕"/>
+                <a:cs typeface="무궁화 고딕"/>
+                <a:sym typeface="무궁화 고딕"/>
               </a:rPr>
               <a:t>어디일까요?</a:t>
             </a:r>
@@ -3879,8 +3875,8 @@
         </p:nvSpPr>
         <p:spPr>
           <a:xfrm rot="0">
-            <a:off x="2717556" y="3933825"/>
-            <a:ext cx="12852888" cy="2124075"/>
+            <a:off x="2717556" y="4219575"/>
+            <a:ext cx="12852888" cy="1838325"/>
           </a:xfrm>
           <a:prstGeom prst="rect">
             <a:avLst/>
@@ -3902,10 +3898,10 @@
                 <a:solidFill>
                   <a:srgbClr val="000000"/>
                 </a:solidFill>
-                <a:latin typeface="Jua"/>
-                <a:ea typeface="Jua"/>
-                <a:cs typeface="Jua"/>
-                <a:sym typeface="Jua"/>
+                <a:latin typeface="무궁화 고딕"/>
+                <a:ea typeface="무궁화 고딕"/>
+                <a:cs typeface="무궁화 고딕"/>
+                <a:sym typeface="무궁화 고딕"/>
               </a:rPr>
               <a:t>고구려</a:t>
             </a:r>
@@ -4002,8 +3998,8 @@
         </p:nvSpPr>
         <p:spPr>
           <a:xfrm rot="0">
-            <a:off x="2717556" y="3019425"/>
-            <a:ext cx="12852888" cy="3952875"/>
+            <a:off x="2717556" y="3305175"/>
+            <a:ext cx="12852888" cy="3667125"/>
           </a:xfrm>
           <a:prstGeom prst="rect">
             <a:avLst/>
@@ -4025,10 +4021,10 @@
                 <a:solidFill>
                   <a:srgbClr val="000000"/>
                 </a:solidFill>
-                <a:latin typeface="Jua"/>
-                <a:ea typeface="Jua"/>
-                <a:cs typeface="Jua"/>
-                <a:sym typeface="Jua"/>
+                <a:latin typeface="무궁화 고딕"/>
+                <a:ea typeface="무궁화 고딕"/>
+                <a:cs typeface="무궁화 고딕"/>
+                <a:sym typeface="무궁화 고딕"/>
               </a:rPr>
               <a:t>6.25 전쟁이 시작된</a:t>
             </a:r>
@@ -4044,10 +4040,10 @@
                 <a:solidFill>
                   <a:srgbClr val="000000"/>
                 </a:solidFill>
-                <a:latin typeface="Jua"/>
-                <a:ea typeface="Jua"/>
-                <a:cs typeface="Jua"/>
-                <a:sym typeface="Jua"/>
+                <a:latin typeface="무궁화 고딕"/>
+                <a:ea typeface="무궁화 고딕"/>
+                <a:cs typeface="무궁화 고딕"/>
+                <a:sym typeface="무궁화 고딕"/>
               </a:rPr>
               <a:t>해는 언제일까요?</a:t>
             </a:r>
@@ -4144,8 +4140,8 @@
         </p:nvSpPr>
         <p:spPr>
           <a:xfrm rot="0">
-            <a:off x="1135011" y="4029075"/>
-            <a:ext cx="16017978" cy="1952625"/>
+            <a:off x="1135011" y="4295775"/>
+            <a:ext cx="16017978" cy="1685925"/>
           </a:xfrm>
           <a:prstGeom prst="rect">
             <a:avLst/>
@@ -4167,10 +4163,10 @@
                 <a:solidFill>
                   <a:srgbClr val="000000"/>
                 </a:solidFill>
-                <a:latin typeface="Jua"/>
-                <a:ea typeface="Jua"/>
-                <a:cs typeface="Jua"/>
-                <a:sym typeface="Jua"/>
+                <a:latin typeface="무궁화 고딕"/>
+                <a:ea typeface="무궁화 고딕"/>
+                <a:cs typeface="무궁화 고딕"/>
+                <a:sym typeface="무궁화 고딕"/>
               </a:rPr>
               <a:t>1950년</a:t>
             </a:r>
@@ -4267,8 +4263,8 @@
         </p:nvSpPr>
         <p:spPr>
           <a:xfrm rot="0">
-            <a:off x="1135011" y="3190875"/>
-            <a:ext cx="16017978" cy="3629025"/>
+            <a:off x="1135011" y="3571875"/>
+            <a:ext cx="16017978" cy="3133725"/>
           </a:xfrm>
           <a:prstGeom prst="rect">
             <a:avLst/>
@@ -4282,18 +4278,18 @@
           <a:p>
             <a:pPr algn="ctr">
               <a:lnSpc>
-                <a:spcPts val="13200"/>
+                <a:spcPts val="12360"/>
               </a:lnSpc>
             </a:pPr>
             <a:r>
-              <a:rPr lang="en-US" sz="11000">
+              <a:rPr lang="en-US" sz="10300">
                 <a:solidFill>
                   <a:srgbClr val="000000"/>
                 </a:solidFill>
-                <a:latin typeface="Jua"/>
-                <a:ea typeface="Jua"/>
-                <a:cs typeface="Jua"/>
-                <a:sym typeface="Jua"/>
+                <a:latin typeface="무궁화 고딕"/>
+                <a:ea typeface="무궁화 고딕"/>
+                <a:cs typeface="무궁화 고딕"/>
+                <a:sym typeface="무궁화 고딕"/>
               </a:rPr>
               <a:t>을지문덕 장군이 승리한 전투는 무엇일까요?</a:t>
             </a:r>
@@ -4390,8 +4386,8 @@
         </p:nvSpPr>
         <p:spPr>
           <a:xfrm rot="0">
-            <a:off x="2717556" y="3933825"/>
-            <a:ext cx="12852888" cy="2124075"/>
+            <a:off x="2717556" y="4219575"/>
+            <a:ext cx="12852888" cy="1838325"/>
           </a:xfrm>
           <a:prstGeom prst="rect">
             <a:avLst/>
@@ -4413,10 +4409,10 @@
                 <a:solidFill>
                   <a:srgbClr val="000000"/>
                 </a:solidFill>
-                <a:latin typeface="Jua"/>
-                <a:ea typeface="Jua"/>
-                <a:cs typeface="Jua"/>
-                <a:sym typeface="Jua"/>
+                <a:latin typeface="무궁화 고딕"/>
+                <a:ea typeface="무궁화 고딕"/>
+                <a:cs typeface="무궁화 고딕"/>
+                <a:sym typeface="무궁화 고딕"/>
               </a:rPr>
               <a:t>살수대첩</a:t>
             </a:r>
@@ -4513,8 +4509,8 @@
         </p:nvSpPr>
         <p:spPr>
           <a:xfrm rot="0">
-            <a:off x="1135011" y="3190875"/>
-            <a:ext cx="16017978" cy="3629025"/>
+            <a:off x="1135011" y="3457575"/>
+            <a:ext cx="16017978" cy="3362325"/>
           </a:xfrm>
           <a:prstGeom prst="rect">
             <a:avLst/>
@@ -4536,10 +4532,10 @@
                 <a:solidFill>
                   <a:srgbClr val="000000"/>
                 </a:solidFill>
-                <a:latin typeface="Jua"/>
-                <a:ea typeface="Jua"/>
-                <a:cs typeface="Jua"/>
-                <a:sym typeface="Jua"/>
+                <a:latin typeface="무궁화 고딕"/>
+                <a:ea typeface="무궁화 고딕"/>
+                <a:cs typeface="무궁화 고딕"/>
+                <a:sym typeface="무궁화 고딕"/>
               </a:rPr>
               <a:t>안중근 의사가 저격한 인물은 누구일까요?</a:t>
             </a:r>
@@ -4688,8 +4684,8 @@
         </p:nvSpPr>
         <p:spPr>
           <a:xfrm rot="0">
-            <a:off x="11392761" y="600705"/>
-            <a:ext cx="5362043" cy="1600200"/>
+            <a:off x="11392761" y="819780"/>
+            <a:ext cx="5362043" cy="1381125"/>
           </a:xfrm>
           <a:prstGeom prst="rect">
             <a:avLst/>
@@ -4711,10 +4707,10 @@
                 <a:solidFill>
                   <a:srgbClr val="FFFAEF"/>
                 </a:solidFill>
-                <a:latin typeface="Jua"/>
-                <a:ea typeface="Jua"/>
-                <a:cs typeface="Jua"/>
-                <a:sym typeface="Jua"/>
+                <a:latin typeface="무궁화 고딕"/>
+                <a:ea typeface="무궁화 고딕"/>
+                <a:cs typeface="무궁화 고딕"/>
+                <a:sym typeface="무궁화 고딕"/>
               </a:rPr>
               <a:t>규칙</a:t>
             </a:r>
@@ -4730,9 +4726,9 @@
         <p:grpSpPr>
           <a:xfrm rot="0">
             <a:off x="217650" y="223900"/>
-            <a:ext cx="10360529" cy="2056505"/>
+            <a:ext cx="10360529" cy="1896543"/>
             <a:chOff x="0" y="0"/>
-            <a:chExt cx="13814039" cy="2742007"/>
+            <a:chExt cx="13814039" cy="2528724"/>
           </a:xfrm>
         </p:grpSpPr>
         <p:sp>
@@ -4743,8 +4739,8 @@
           </p:nvSpPr>
           <p:spPr>
             <a:xfrm rot="0">
-              <a:off x="0" y="1625465"/>
-              <a:ext cx="13814039" cy="1116542"/>
+              <a:off x="0" y="1648191"/>
+              <a:ext cx="13814039" cy="880533"/>
             </a:xfrm>
             <a:prstGeom prst="rect">
               <a:avLst/>
@@ -4758,18 +4754,18 @@
             <a:p>
               <a:pPr algn="l">
                 <a:lnSpc>
-                  <a:spcPts val="7000"/>
+                  <a:spcPts val="5599"/>
                 </a:lnSpc>
               </a:pPr>
               <a:r>
-                <a:rPr lang="en-US" sz="5000">
+                <a:rPr lang="en-US" sz="3999">
                   <a:solidFill>
                     <a:srgbClr val="FFFAEF"/>
                   </a:solidFill>
-                  <a:latin typeface="TDTD가온"/>
-                  <a:ea typeface="TDTD가온"/>
-                  <a:cs typeface="TDTD가온"/>
-                  <a:sym typeface="TDTD가온"/>
+                  <a:latin typeface="무궁화 고딕"/>
+                  <a:ea typeface="무궁화 고딕"/>
+                  <a:cs typeface="무궁화 고딕"/>
+                  <a:sym typeface="무궁화 고딕"/>
                 </a:rPr>
                 <a:t>화면에 역사 문제가 나타납니다.</a:t>
               </a:r>
@@ -4784,8 +4780,8 @@
           </p:nvSpPr>
           <p:spPr>
             <a:xfrm rot="0">
-              <a:off x="0" y="-190500"/>
-              <a:ext cx="11298371" cy="1367863"/>
+              <a:off x="0" y="-66675"/>
+              <a:ext cx="11298371" cy="1238189"/>
             </a:xfrm>
             <a:prstGeom prst="rect">
               <a:avLst/>
@@ -4807,10 +4803,10 @@
                   <a:solidFill>
                     <a:srgbClr val="FFFAEF"/>
                   </a:solidFill>
-                  <a:latin typeface="Jua"/>
-                  <a:ea typeface="Jua"/>
-                  <a:cs typeface="Jua"/>
-                  <a:sym typeface="Jua"/>
+                  <a:latin typeface="무궁화 고딕 Bold"/>
+                  <a:ea typeface="무궁화 고딕 Bold"/>
+                  <a:cs typeface="무궁화 고딕 Bold"/>
+                  <a:sym typeface="무궁화 고딕 Bold"/>
                 </a:rPr>
                 <a:t>STEP 1.</a:t>
               </a:r>
@@ -4826,10 +4822,10 @@
         </p:nvGrpSpPr>
         <p:grpSpPr>
           <a:xfrm rot="0">
-            <a:off x="9144000" y="7809938"/>
-            <a:ext cx="9144000" cy="1994512"/>
+            <a:off x="10578180" y="8070622"/>
+            <a:ext cx="7299158" cy="1838937"/>
             <a:chOff x="0" y="0"/>
-            <a:chExt cx="12192000" cy="2659349"/>
+            <a:chExt cx="9732211" cy="2451916"/>
           </a:xfrm>
         </p:grpSpPr>
         <p:sp>
@@ -4840,8 +4836,8 @@
           </p:nvSpPr>
           <p:spPr>
             <a:xfrm rot="0">
-              <a:off x="0" y="1542808"/>
-              <a:ext cx="12076089" cy="1116541"/>
+              <a:off x="0" y="1571383"/>
+              <a:ext cx="9639685" cy="880533"/>
             </a:xfrm>
             <a:prstGeom prst="rect">
               <a:avLst/>
@@ -4855,18 +4851,18 @@
             <a:p>
               <a:pPr algn="l">
                 <a:lnSpc>
-                  <a:spcPts val="7000"/>
+                  <a:spcPts val="5599"/>
                 </a:lnSpc>
               </a:pPr>
               <a:r>
-                <a:rPr lang="en-US" sz="5000">
+                <a:rPr lang="en-US" sz="3999">
                   <a:solidFill>
                     <a:srgbClr val="FFFAEF"/>
                   </a:solidFill>
-                  <a:latin typeface="TDTD가온"/>
-                  <a:ea typeface="TDTD가온"/>
-                  <a:cs typeface="TDTD가온"/>
-                  <a:sym typeface="TDTD가온"/>
+                  <a:latin typeface="무궁화 고딕"/>
+                  <a:ea typeface="무궁화 고딕"/>
+                  <a:cs typeface="무궁화 고딕"/>
+                  <a:sym typeface="무궁화 고딕"/>
                 </a:rPr>
                 <a:t>가장 많은 문제를 맞춘  팀이 우승!</a:t>
               </a:r>
@@ -4881,8 +4877,8 @@
           </p:nvSpPr>
           <p:spPr>
             <a:xfrm rot="0">
-              <a:off x="0" y="-190500"/>
-              <a:ext cx="12192000" cy="1374479"/>
+              <a:off x="0" y="-57150"/>
+              <a:ext cx="9732211" cy="1241129"/>
             </a:xfrm>
             <a:prstGeom prst="rect">
               <a:avLst/>
@@ -4904,10 +4900,10 @@
                   <a:solidFill>
                     <a:srgbClr val="FFFAEF"/>
                   </a:solidFill>
-                  <a:latin typeface="Jua"/>
-                  <a:ea typeface="Jua"/>
-                  <a:cs typeface="Jua"/>
-                  <a:sym typeface="Jua"/>
+                  <a:latin typeface="무궁화 고딕 Bold"/>
+                  <a:ea typeface="무궁화 고딕 Bold"/>
+                  <a:cs typeface="무궁화 고딕 Bold"/>
+                  <a:sym typeface="무궁화 고딕 Bold"/>
                 </a:rPr>
                 <a:t>STEP 3.</a:t>
               </a:r>
@@ -4923,10 +4919,10 @@
         </p:nvGrpSpPr>
         <p:grpSpPr>
           <a:xfrm rot="0">
-            <a:off x="5397915" y="3511566"/>
-            <a:ext cx="7371077" cy="2939517"/>
+            <a:off x="5397915" y="3837348"/>
+            <a:ext cx="7371077" cy="2596832"/>
             <a:chOff x="0" y="0"/>
-            <a:chExt cx="9828103" cy="3919356"/>
+            <a:chExt cx="9828103" cy="3462442"/>
           </a:xfrm>
         </p:grpSpPr>
         <p:sp>
@@ -4937,8 +4933,8 @@
           </p:nvSpPr>
           <p:spPr>
             <a:xfrm rot="0">
-              <a:off x="0" y="1631121"/>
-              <a:ext cx="9828103" cy="2288235"/>
+              <a:off x="0" y="1642109"/>
+              <a:ext cx="9828103" cy="1820333"/>
             </a:xfrm>
             <a:prstGeom prst="rect">
               <a:avLst/>
@@ -4952,18 +4948,18 @@
             <a:p>
               <a:pPr algn="l">
                 <a:lnSpc>
-                  <a:spcPts val="6995"/>
+                  <a:spcPts val="5599"/>
                 </a:lnSpc>
               </a:pPr>
               <a:r>
-                <a:rPr lang="en-US" sz="4996">
+                <a:rPr lang="en-US" sz="3999">
                   <a:solidFill>
                     <a:srgbClr val="FFFAEF"/>
                   </a:solidFill>
-                  <a:latin typeface="TDTD가온"/>
-                  <a:ea typeface="TDTD가온"/>
-                  <a:cs typeface="TDTD가온"/>
-                  <a:sym typeface="TDTD가온"/>
+                  <a:latin typeface="무궁화 고딕"/>
+                  <a:ea typeface="무궁화 고딕"/>
+                  <a:cs typeface="무궁화 고딕"/>
+                  <a:sym typeface="무궁화 고딕"/>
                 </a:rPr>
                 <a:t>팀 구호(혹은 정답)를 가장 먼저</a:t>
               </a:r>
@@ -4971,18 +4967,18 @@
             <a:p>
               <a:pPr algn="l">
                 <a:lnSpc>
-                  <a:spcPts val="6995"/>
+                  <a:spcPts val="5599"/>
                 </a:lnSpc>
               </a:pPr>
               <a:r>
-                <a:rPr lang="en-US" sz="4996">
+                <a:rPr lang="en-US" sz="3999">
                   <a:solidFill>
                     <a:srgbClr val="FFFAEF"/>
                   </a:solidFill>
-                  <a:latin typeface="TDTD가온"/>
-                  <a:ea typeface="TDTD가온"/>
-                  <a:cs typeface="TDTD가온"/>
-                  <a:sym typeface="TDTD가온"/>
+                  <a:latin typeface="무궁화 고딕"/>
+                  <a:ea typeface="무궁화 고딕"/>
+                  <a:cs typeface="무궁화 고딕"/>
+                  <a:sym typeface="무궁화 고딕"/>
                 </a:rPr>
                 <a:t>외친 팀에게 기회가 주어집니다.</a:t>
               </a:r>
@@ -4997,8 +4993,8 @@
           </p:nvSpPr>
           <p:spPr>
             <a:xfrm rot="0">
-              <a:off x="0" y="-190500"/>
-              <a:ext cx="5178984" cy="1369906"/>
+              <a:off x="0" y="-66675"/>
+              <a:ext cx="5178984" cy="1238018"/>
             </a:xfrm>
             <a:prstGeom prst="rect">
               <a:avLst/>
@@ -5020,10 +5016,10 @@
                   <a:solidFill>
                     <a:srgbClr val="FFFAEF"/>
                   </a:solidFill>
-                  <a:latin typeface="Jua"/>
-                  <a:ea typeface="Jua"/>
-                  <a:cs typeface="Jua"/>
-                  <a:sym typeface="Jua"/>
+                  <a:latin typeface="무궁화 고딕 Bold"/>
+                  <a:ea typeface="무궁화 고딕 Bold"/>
+                  <a:cs typeface="무궁화 고딕 Bold"/>
+                  <a:sym typeface="무궁화 고딕 Bold"/>
                 </a:rPr>
                 <a:t>STEP 2.</a:t>
               </a:r>
@@ -5121,8 +5117,8 @@
         </p:nvSpPr>
         <p:spPr>
           <a:xfrm rot="0">
-            <a:off x="2717556" y="3933825"/>
-            <a:ext cx="12852888" cy="2124075"/>
+            <a:off x="2717556" y="4219575"/>
+            <a:ext cx="12852888" cy="1838325"/>
           </a:xfrm>
           <a:prstGeom prst="rect">
             <a:avLst/>
@@ -5144,10 +5140,10 @@
                 <a:solidFill>
                   <a:srgbClr val="000000"/>
                 </a:solidFill>
-                <a:latin typeface="Jua"/>
-                <a:ea typeface="Jua"/>
-                <a:cs typeface="Jua"/>
-                <a:sym typeface="Jua"/>
+                <a:latin typeface="무궁화 고딕"/>
+                <a:ea typeface="무궁화 고딕"/>
+                <a:cs typeface="무궁화 고딕"/>
+                <a:sym typeface="무궁화 고딕"/>
               </a:rPr>
               <a:t>이토 히로부미</a:t>
             </a:r>
@@ -5244,8 +5240,8 @@
         </p:nvSpPr>
         <p:spPr>
           <a:xfrm rot="0">
-            <a:off x="1135011" y="3190875"/>
-            <a:ext cx="16017978" cy="3629025"/>
+            <a:off x="1135011" y="3457575"/>
+            <a:ext cx="16017978" cy="3362325"/>
           </a:xfrm>
           <a:prstGeom prst="rect">
             <a:avLst/>
@@ -5267,10 +5263,10 @@
                 <a:solidFill>
                   <a:srgbClr val="000000"/>
                 </a:solidFill>
-                <a:latin typeface="Jua"/>
-                <a:ea typeface="Jua"/>
-                <a:cs typeface="Jua"/>
-                <a:sym typeface="Jua"/>
+                <a:latin typeface="무궁화 고딕"/>
+                <a:ea typeface="무궁화 고딕"/>
+                <a:cs typeface="무궁화 고딕"/>
+                <a:sym typeface="무궁화 고딕"/>
               </a:rPr>
               <a:t>1000원짜리 지폐에 있는</a:t>
             </a:r>
@@ -5286,10 +5282,10 @@
                 <a:solidFill>
                   <a:srgbClr val="000000"/>
                 </a:solidFill>
-                <a:latin typeface="Jua"/>
-                <a:ea typeface="Jua"/>
-                <a:cs typeface="Jua"/>
-                <a:sym typeface="Jua"/>
+                <a:latin typeface="무궁화 고딕"/>
+                <a:ea typeface="무궁화 고딕"/>
+                <a:cs typeface="무궁화 고딕"/>
+                <a:sym typeface="무궁화 고딕"/>
               </a:rPr>
               <a:t>인물은 누구일까요?</a:t>
             </a:r>
@@ -5386,8 +5382,8 @@
         </p:nvSpPr>
         <p:spPr>
           <a:xfrm rot="0">
-            <a:off x="2717556" y="3933825"/>
-            <a:ext cx="12852888" cy="2124075"/>
+            <a:off x="2717556" y="4219575"/>
+            <a:ext cx="12852888" cy="1838325"/>
           </a:xfrm>
           <a:prstGeom prst="rect">
             <a:avLst/>
@@ -5409,10 +5405,10 @@
                 <a:solidFill>
                   <a:srgbClr val="000000"/>
                 </a:solidFill>
-                <a:latin typeface="Jua"/>
-                <a:ea typeface="Jua"/>
-                <a:cs typeface="Jua"/>
-                <a:sym typeface="Jua"/>
+                <a:latin typeface="무궁화 고딕"/>
+                <a:ea typeface="무궁화 고딕"/>
+                <a:cs typeface="무궁화 고딕"/>
+                <a:sym typeface="무궁화 고딕"/>
               </a:rPr>
               <a:t>율곡 이이</a:t>
             </a:r>
@@ -5509,8 +5505,8 @@
         </p:nvSpPr>
         <p:spPr>
           <a:xfrm rot="0">
-            <a:off x="1135011" y="4029075"/>
-            <a:ext cx="16017978" cy="1952625"/>
+            <a:off x="1135011" y="4295775"/>
+            <a:ext cx="16017978" cy="1685925"/>
           </a:xfrm>
           <a:prstGeom prst="rect">
             <a:avLst/>
@@ -5532,10 +5528,10 @@
                 <a:solidFill>
                   <a:srgbClr val="000000"/>
                 </a:solidFill>
-                <a:latin typeface="Jua"/>
-                <a:ea typeface="Jua"/>
-                <a:cs typeface="Jua"/>
-                <a:sym typeface="Jua"/>
+                <a:latin typeface="무궁화 고딕"/>
+                <a:ea typeface="무궁화 고딕"/>
+                <a:cs typeface="무궁화 고딕"/>
+                <a:sym typeface="무궁화 고딕"/>
               </a:rPr>
               <a:t>한글날은 몇 월 며칠일까요?</a:t>
             </a:r>
@@ -5632,8 +5628,8 @@
         </p:nvSpPr>
         <p:spPr>
           <a:xfrm rot="0">
-            <a:off x="2717556" y="3933825"/>
-            <a:ext cx="12852888" cy="2124075"/>
+            <a:off x="2717556" y="4219575"/>
+            <a:ext cx="12852888" cy="1838325"/>
           </a:xfrm>
           <a:prstGeom prst="rect">
             <a:avLst/>
@@ -5655,10 +5651,10 @@
                 <a:solidFill>
                   <a:srgbClr val="000000"/>
                 </a:solidFill>
-                <a:latin typeface="Jua"/>
-                <a:ea typeface="Jua"/>
-                <a:cs typeface="Jua"/>
-                <a:sym typeface="Jua"/>
+                <a:latin typeface="무궁화 고딕"/>
+                <a:ea typeface="무궁화 고딕"/>
+                <a:cs typeface="무궁화 고딕"/>
+                <a:sym typeface="무궁화 고딕"/>
               </a:rPr>
               <a:t>10월 9일</a:t>
             </a:r>
@@ -5755,8 +5751,8 @@
         </p:nvSpPr>
         <p:spPr>
           <a:xfrm rot="0">
-            <a:off x="1135011" y="4119562"/>
-            <a:ext cx="16017978" cy="1800225"/>
+            <a:off x="1135011" y="4410075"/>
+            <a:ext cx="16017978" cy="1457325"/>
           </a:xfrm>
           <a:prstGeom prst="rect">
             <a:avLst/>
@@ -5770,18 +5766,18 @@
           <a:p>
             <a:pPr algn="ctr">
               <a:lnSpc>
-                <a:spcPts val="12240"/>
+                <a:spcPts val="11400"/>
               </a:lnSpc>
             </a:pPr>
             <a:r>
-              <a:rPr lang="en-US" sz="10200">
+              <a:rPr lang="en-US" sz="9500">
                 <a:solidFill>
                   <a:srgbClr val="000000"/>
                 </a:solidFill>
-                <a:latin typeface="Jua"/>
-                <a:ea typeface="Jua"/>
-                <a:cs typeface="Jua"/>
-                <a:sym typeface="Jua"/>
+                <a:latin typeface="무궁화 고딕"/>
+                <a:ea typeface="무궁화 고딕"/>
+                <a:cs typeface="무궁화 고딕"/>
+                <a:sym typeface="무궁화 고딕"/>
               </a:rPr>
               <a:t>우리나라 국보 1호는 무엇일까요?</a:t>
             </a:r>
@@ -5878,8 +5874,8 @@
         </p:nvSpPr>
         <p:spPr>
           <a:xfrm rot="0">
-            <a:off x="2717556" y="3933825"/>
-            <a:ext cx="12852888" cy="2124075"/>
+            <a:off x="2717556" y="4219575"/>
+            <a:ext cx="12852888" cy="1838325"/>
           </a:xfrm>
           <a:prstGeom prst="rect">
             <a:avLst/>
@@ -5901,10 +5897,10 @@
                 <a:solidFill>
                   <a:srgbClr val="000000"/>
                 </a:solidFill>
-                <a:latin typeface="Jua"/>
-                <a:ea typeface="Jua"/>
-                <a:cs typeface="Jua"/>
-                <a:sym typeface="Jua"/>
+                <a:latin typeface="무궁화 고딕"/>
+                <a:ea typeface="무궁화 고딕"/>
+                <a:cs typeface="무궁화 고딕"/>
+                <a:sym typeface="무궁화 고딕"/>
               </a:rPr>
               <a:t>숭례문</a:t>
             </a:r>
@@ -6001,8 +5997,8 @@
         </p:nvSpPr>
         <p:spPr>
           <a:xfrm rot="0">
-            <a:off x="1135011" y="4119562"/>
-            <a:ext cx="16017978" cy="1800225"/>
+            <a:off x="1135011" y="4410075"/>
+            <a:ext cx="16017978" cy="1457325"/>
           </a:xfrm>
           <a:prstGeom prst="rect">
             <a:avLst/>
@@ -6016,18 +6012,18 @@
           <a:p>
             <a:pPr algn="ctr">
               <a:lnSpc>
-                <a:spcPts val="12240"/>
+                <a:spcPts val="11400"/>
               </a:lnSpc>
             </a:pPr>
             <a:r>
-              <a:rPr lang="en-US" sz="10200">
+              <a:rPr lang="en-US" sz="9500">
                 <a:solidFill>
                   <a:srgbClr val="000000"/>
                 </a:solidFill>
-                <a:latin typeface="Jua"/>
-                <a:ea typeface="Jua"/>
-                <a:cs typeface="Jua"/>
-                <a:sym typeface="Jua"/>
+                <a:latin typeface="무궁화 고딕"/>
+                <a:ea typeface="무궁화 고딕"/>
+                <a:cs typeface="무궁화 고딕"/>
+                <a:sym typeface="무궁화 고딕"/>
               </a:rPr>
               <a:t>독도는 어느 도에 속해 있을까요?</a:t>
             </a:r>
@@ -6124,8 +6120,8 @@
         </p:nvSpPr>
         <p:spPr>
           <a:xfrm rot="0">
-            <a:off x="2717556" y="3933825"/>
-            <a:ext cx="12852888" cy="2124075"/>
+            <a:off x="2717556" y="4219575"/>
+            <a:ext cx="12852888" cy="1838325"/>
           </a:xfrm>
           <a:prstGeom prst="rect">
             <a:avLst/>
@@ -6147,10 +6143,10 @@
                 <a:solidFill>
                   <a:srgbClr val="000000"/>
                 </a:solidFill>
-                <a:latin typeface="Jua"/>
-                <a:ea typeface="Jua"/>
-                <a:cs typeface="Jua"/>
-                <a:sym typeface="Jua"/>
+                <a:latin typeface="무궁화 고딕"/>
+                <a:ea typeface="무궁화 고딕"/>
+                <a:cs typeface="무궁화 고딕"/>
+                <a:sym typeface="무궁화 고딕"/>
               </a:rPr>
               <a:t>경상북도</a:t>
             </a:r>
@@ -6247,8 +6243,8 @@
         </p:nvSpPr>
         <p:spPr>
           <a:xfrm rot="0">
-            <a:off x="1135011" y="3190875"/>
-            <a:ext cx="16017978" cy="3629025"/>
+            <a:off x="1135011" y="3457575"/>
+            <a:ext cx="16017978" cy="3362325"/>
           </a:xfrm>
           <a:prstGeom prst="rect">
             <a:avLst/>
@@ -6270,10 +6266,10 @@
                 <a:solidFill>
                   <a:srgbClr val="000000"/>
                 </a:solidFill>
-                <a:latin typeface="Jua"/>
-                <a:ea typeface="Jua"/>
-                <a:cs typeface="Jua"/>
-                <a:sym typeface="Jua"/>
+                <a:latin typeface="무궁화 고딕"/>
+                <a:ea typeface="무궁화 고딕"/>
+                <a:cs typeface="무궁화 고딕"/>
+                <a:sym typeface="무궁화 고딕"/>
               </a:rPr>
               <a:t>대한민국의 초대 대통령은</a:t>
             </a:r>
@@ -6289,10 +6285,10 @@
                 <a:solidFill>
                   <a:srgbClr val="000000"/>
                 </a:solidFill>
-                <a:latin typeface="Jua"/>
-                <a:ea typeface="Jua"/>
-                <a:cs typeface="Jua"/>
-                <a:sym typeface="Jua"/>
+                <a:latin typeface="무궁화 고딕"/>
+                <a:ea typeface="무궁화 고딕"/>
+                <a:cs typeface="무궁화 고딕"/>
+                <a:sym typeface="무궁화 고딕"/>
               </a:rPr>
               <a:t>누구일까요?</a:t>
             </a:r>
@@ -6339,8 +6335,8 @@
         </p:nvSpPr>
         <p:spPr>
           <a:xfrm rot="0">
-            <a:off x="3238925" y="4092795"/>
-            <a:ext cx="11810151" cy="2200275"/>
+            <a:off x="3238925" y="4378545"/>
+            <a:ext cx="11810151" cy="1914525"/>
           </a:xfrm>
           <a:prstGeom prst="rect">
             <a:avLst/>
@@ -6362,10 +6358,10 @@
                 <a:solidFill>
                   <a:srgbClr val="000000"/>
                 </a:solidFill>
-                <a:latin typeface="Jua"/>
-                <a:ea typeface="Jua"/>
-                <a:cs typeface="Jua"/>
-                <a:sym typeface="Jua"/>
+                <a:latin typeface="무궁화 고딕"/>
+                <a:ea typeface="무궁화 고딕"/>
+                <a:cs typeface="무궁화 고딕"/>
+                <a:sym typeface="무궁화 고딕"/>
               </a:rPr>
               <a:t>팀을 나눠주세요!</a:t>
             </a:r>
@@ -6512,8 +6508,8 @@
         </p:nvSpPr>
         <p:spPr>
           <a:xfrm rot="0">
-            <a:off x="2717556" y="3933825"/>
-            <a:ext cx="12852888" cy="2124075"/>
+            <a:off x="2717556" y="4219575"/>
+            <a:ext cx="12852888" cy="1838325"/>
           </a:xfrm>
           <a:prstGeom prst="rect">
             <a:avLst/>
@@ -6535,10 +6531,10 @@
                 <a:solidFill>
                   <a:srgbClr val="000000"/>
                 </a:solidFill>
-                <a:latin typeface="Jua"/>
-                <a:ea typeface="Jua"/>
-                <a:cs typeface="Jua"/>
-                <a:sym typeface="Jua"/>
+                <a:latin typeface="무궁화 고딕"/>
+                <a:ea typeface="무궁화 고딕"/>
+                <a:cs typeface="무궁화 고딕"/>
+                <a:sym typeface="무궁화 고딕"/>
               </a:rPr>
               <a:t>이승만</a:t>
             </a:r>
@@ -6635,8 +6631,8 @@
         </p:nvSpPr>
         <p:spPr>
           <a:xfrm rot="0">
-            <a:off x="1135011" y="4029075"/>
-            <a:ext cx="16017978" cy="1952625"/>
+            <a:off x="1135011" y="4343400"/>
+            <a:ext cx="16017978" cy="1590675"/>
           </a:xfrm>
           <a:prstGeom prst="rect">
             <a:avLst/>
@@ -6650,18 +6646,18 @@
           <a:p>
             <a:pPr algn="ctr">
               <a:lnSpc>
-                <a:spcPts val="13200"/>
+                <a:spcPts val="12480"/>
               </a:lnSpc>
             </a:pPr>
             <a:r>
-              <a:rPr lang="en-US" sz="11000">
+              <a:rPr lang="en-US" sz="10400">
                 <a:solidFill>
                   <a:srgbClr val="000000"/>
                 </a:solidFill>
-                <a:latin typeface="Jua"/>
-                <a:ea typeface="Jua"/>
-                <a:cs typeface="Jua"/>
-                <a:sym typeface="Jua"/>
+                <a:latin typeface="무궁화 고딕"/>
+                <a:ea typeface="무궁화 고딕"/>
+                <a:cs typeface="무궁화 고딕"/>
+                <a:sym typeface="무궁화 고딕"/>
               </a:rPr>
               <a:t>서울의 옛 이름은 무엇일까요?</a:t>
             </a:r>
@@ -6758,8 +6754,8 @@
         </p:nvSpPr>
         <p:spPr>
           <a:xfrm rot="0">
-            <a:off x="2717556" y="3933825"/>
-            <a:ext cx="12852888" cy="2124075"/>
+            <a:off x="2717556" y="4219575"/>
+            <a:ext cx="12852888" cy="1838325"/>
           </a:xfrm>
           <a:prstGeom prst="rect">
             <a:avLst/>
@@ -6781,10 +6777,10 @@
                 <a:solidFill>
                   <a:srgbClr val="000000"/>
                 </a:solidFill>
-                <a:latin typeface="Jua"/>
-                <a:ea typeface="Jua"/>
-                <a:cs typeface="Jua"/>
-                <a:sym typeface="Jua"/>
+                <a:latin typeface="무궁화 고딕"/>
+                <a:ea typeface="무궁화 고딕"/>
+                <a:cs typeface="무궁화 고딕"/>
+                <a:sym typeface="무궁화 고딕"/>
               </a:rPr>
               <a:t>한양</a:t>
             </a:r>
@@ -6881,8 +6877,8 @@
         </p:nvSpPr>
         <p:spPr>
           <a:xfrm rot="0">
-            <a:off x="1135011" y="3190875"/>
-            <a:ext cx="16017978" cy="3629025"/>
+            <a:off x="1135011" y="3457575"/>
+            <a:ext cx="16017978" cy="3362325"/>
           </a:xfrm>
           <a:prstGeom prst="rect">
             <a:avLst/>
@@ -6904,10 +6900,10 @@
                 <a:solidFill>
                   <a:srgbClr val="000000"/>
                 </a:solidFill>
-                <a:latin typeface="Jua"/>
-                <a:ea typeface="Jua"/>
-                <a:cs typeface="Jua"/>
-                <a:sym typeface="Jua"/>
+                <a:latin typeface="무궁화 고딕"/>
+                <a:ea typeface="무궁화 고딕"/>
+                <a:cs typeface="무궁화 고딕"/>
+                <a:sym typeface="무궁화 고딕"/>
               </a:rPr>
               <a:t>태극기의 네 모서리 괘를</a:t>
             </a:r>
@@ -6923,10 +6919,10 @@
                 <a:solidFill>
                   <a:srgbClr val="000000"/>
                 </a:solidFill>
-                <a:latin typeface="Jua"/>
-                <a:ea typeface="Jua"/>
-                <a:cs typeface="Jua"/>
-                <a:sym typeface="Jua"/>
+                <a:latin typeface="무궁화 고딕"/>
+                <a:ea typeface="무궁화 고딕"/>
+                <a:cs typeface="무궁화 고딕"/>
+                <a:sym typeface="무궁화 고딕"/>
               </a:rPr>
               <a:t>뭐라고 할까요?</a:t>
             </a:r>
@@ -7023,8 +7019,8 @@
         </p:nvSpPr>
         <p:spPr>
           <a:xfrm rot="0">
-            <a:off x="2717556" y="3933825"/>
-            <a:ext cx="12852888" cy="2124075"/>
+            <a:off x="2717556" y="4219575"/>
+            <a:ext cx="12852888" cy="1838325"/>
           </a:xfrm>
           <a:prstGeom prst="rect">
             <a:avLst/>
@@ -7046,10 +7042,10 @@
                 <a:solidFill>
                   <a:srgbClr val="000000"/>
                 </a:solidFill>
-                <a:latin typeface="Jua"/>
-                <a:ea typeface="Jua"/>
-                <a:cs typeface="Jua"/>
-                <a:sym typeface="Jua"/>
+                <a:latin typeface="무궁화 고딕"/>
+                <a:ea typeface="무궁화 고딕"/>
+                <a:cs typeface="무궁화 고딕"/>
+                <a:sym typeface="무궁화 고딕"/>
               </a:rPr>
               <a:t>건곤감리</a:t>
             </a:r>
@@ -7146,8 +7142,8 @@
         </p:nvSpPr>
         <p:spPr>
           <a:xfrm rot="0">
-            <a:off x="1135011" y="3190875"/>
-            <a:ext cx="16017978" cy="3629025"/>
+            <a:off x="1135011" y="3457575"/>
+            <a:ext cx="16017978" cy="3362325"/>
           </a:xfrm>
           <a:prstGeom prst="rect">
             <a:avLst/>
@@ -7169,10 +7165,10 @@
                 <a:solidFill>
                   <a:srgbClr val="000000"/>
                 </a:solidFill>
-                <a:latin typeface="Jua"/>
-                <a:ea typeface="Jua"/>
-                <a:cs typeface="Jua"/>
-                <a:sym typeface="Jua"/>
+                <a:latin typeface="무궁화 고딕"/>
+                <a:ea typeface="무궁화 고딕"/>
+                <a:cs typeface="무궁화 고딕"/>
+                <a:sym typeface="무궁화 고딕"/>
               </a:rPr>
               <a:t>우리나라에서 가장 높은 산은 무엇일까요?</a:t>
             </a:r>
@@ -7269,8 +7265,8 @@
         </p:nvSpPr>
         <p:spPr>
           <a:xfrm rot="0">
-            <a:off x="2717556" y="3933825"/>
-            <a:ext cx="12852888" cy="2124075"/>
+            <a:off x="2717556" y="4219575"/>
+            <a:ext cx="12852888" cy="1838325"/>
           </a:xfrm>
           <a:prstGeom prst="rect">
             <a:avLst/>
@@ -7292,10 +7288,10 @@
                 <a:solidFill>
                   <a:srgbClr val="000000"/>
                 </a:solidFill>
-                <a:latin typeface="Jua"/>
-                <a:ea typeface="Jua"/>
-                <a:cs typeface="Jua"/>
-                <a:sym typeface="Jua"/>
+                <a:latin typeface="무궁화 고딕"/>
+                <a:ea typeface="무궁화 고딕"/>
+                <a:cs typeface="무궁화 고딕"/>
+                <a:sym typeface="무궁화 고딕"/>
               </a:rPr>
               <a:t>한라산(1947m)</a:t>
             </a:r>
@@ -7392,8 +7388,8 @@
         </p:nvSpPr>
         <p:spPr>
           <a:xfrm rot="0">
-            <a:off x="1135011" y="3190875"/>
-            <a:ext cx="16017978" cy="3629025"/>
+            <a:off x="1135011" y="3457575"/>
+            <a:ext cx="16017978" cy="3362325"/>
           </a:xfrm>
           <a:prstGeom prst="rect">
             <a:avLst/>
@@ -7415,10 +7411,10 @@
                 <a:solidFill>
                   <a:srgbClr val="000000"/>
                 </a:solidFill>
-                <a:latin typeface="Jua"/>
-                <a:ea typeface="Jua"/>
-                <a:cs typeface="Jua"/>
-                <a:sym typeface="Jua"/>
+                <a:latin typeface="무궁화 고딕"/>
+                <a:ea typeface="무궁화 고딕"/>
+                <a:cs typeface="무궁화 고딕"/>
+                <a:sym typeface="무궁화 고딕"/>
               </a:rPr>
               <a:t>만리장성을 처음 만든 황제는 누구일까요?</a:t>
             </a:r>
@@ -7515,8 +7511,8 @@
         </p:nvSpPr>
         <p:spPr>
           <a:xfrm rot="0">
-            <a:off x="2717556" y="3933825"/>
-            <a:ext cx="12852888" cy="2124075"/>
+            <a:off x="2717556" y="4219575"/>
+            <a:ext cx="12852888" cy="1838325"/>
           </a:xfrm>
           <a:prstGeom prst="rect">
             <a:avLst/>
@@ -7538,10 +7534,10 @@
                 <a:solidFill>
                   <a:srgbClr val="000000"/>
                 </a:solidFill>
-                <a:latin typeface="Jua"/>
-                <a:ea typeface="Jua"/>
-                <a:cs typeface="Jua"/>
-                <a:sym typeface="Jua"/>
+                <a:latin typeface="무궁화 고딕"/>
+                <a:ea typeface="무궁화 고딕"/>
+                <a:cs typeface="무궁화 고딕"/>
+                <a:sym typeface="무궁화 고딕"/>
               </a:rPr>
               <a:t>진시황</a:t>
             </a:r>
@@ -7638,8 +7634,8 @@
         </p:nvSpPr>
         <p:spPr>
           <a:xfrm rot="0">
-            <a:off x="1135011" y="3190875"/>
-            <a:ext cx="16017978" cy="3629025"/>
+            <a:off x="1135011" y="3457575"/>
+            <a:ext cx="16017978" cy="3362325"/>
           </a:xfrm>
           <a:prstGeom prst="rect">
             <a:avLst/>
@@ -7661,10 +7657,10 @@
                 <a:solidFill>
                   <a:srgbClr val="000000"/>
                 </a:solidFill>
-                <a:latin typeface="Jua"/>
-                <a:ea typeface="Jua"/>
-                <a:cs typeface="Jua"/>
-                <a:sym typeface="Jua"/>
+                <a:latin typeface="무궁화 고딕"/>
+                <a:ea typeface="무궁화 고딕"/>
+                <a:cs typeface="무궁화 고딕"/>
+                <a:sym typeface="무궁화 고딕"/>
               </a:rPr>
               <a:t>최초로 비행기를 만든 사람은 누구일까요?</a:t>
             </a:r>
@@ -7761,8 +7757,8 @@
         </p:nvSpPr>
         <p:spPr>
           <a:xfrm rot="0">
-            <a:off x="1028700" y="3892867"/>
-            <a:ext cx="15555091" cy="2200275"/>
+            <a:off x="1028700" y="4178617"/>
+            <a:ext cx="15555091" cy="1914525"/>
           </a:xfrm>
           <a:prstGeom prst="rect">
             <a:avLst/>
@@ -7784,10 +7780,10 @@
                 <a:solidFill>
                   <a:srgbClr val="FFFAEF"/>
                 </a:solidFill>
-                <a:latin typeface="Jua"/>
-                <a:ea typeface="Jua"/>
-                <a:cs typeface="Jua"/>
-                <a:sym typeface="Jua"/>
+                <a:latin typeface="무궁화 고딕"/>
+                <a:ea typeface="무궁화 고딕"/>
+                <a:cs typeface="무궁화 고딕"/>
+                <a:sym typeface="무궁화 고딕"/>
               </a:rPr>
               <a:t>역사 퀴즈</a:t>
             </a:r>
@@ -7802,8 +7798,8 @@
         </p:nvSpPr>
         <p:spPr>
           <a:xfrm rot="0">
-            <a:off x="15264803" y="9812655"/>
-            <a:ext cx="2637975" cy="474345"/>
+            <a:off x="14743435" y="9822180"/>
+            <a:ext cx="3159344" cy="464820"/>
           </a:xfrm>
           <a:prstGeom prst="rect">
             <a:avLst/>
@@ -7828,10 +7824,10 @@
                 <a:solidFill>
                   <a:srgbClr val="FFFFFF"/>
                 </a:solidFill>
-                <a:latin typeface="TDTD갬성명조"/>
-                <a:ea typeface="TDTD갬성명조"/>
-                <a:cs typeface="TDTD갬성명조"/>
-                <a:sym typeface="TDTD갬성명조"/>
+                <a:latin typeface="무궁화 고딕"/>
+                <a:ea typeface="무궁화 고딕"/>
+                <a:cs typeface="무궁화 고딕"/>
+                <a:sym typeface="무궁화 고딕"/>
               </a:rPr>
               <a:t>ⓒ 2026. Sunday Play</a:t>
             </a:r>
@@ -7928,8 +7924,8 @@
         </p:nvSpPr>
         <p:spPr>
           <a:xfrm rot="0">
-            <a:off x="2717556" y="3933825"/>
-            <a:ext cx="12852888" cy="2124075"/>
+            <a:off x="2717556" y="4219575"/>
+            <a:ext cx="12852888" cy="1838325"/>
           </a:xfrm>
           <a:prstGeom prst="rect">
             <a:avLst/>
@@ -7951,10 +7947,10 @@
                 <a:solidFill>
                   <a:srgbClr val="000000"/>
                 </a:solidFill>
-                <a:latin typeface="Jua"/>
-                <a:ea typeface="Jua"/>
-                <a:cs typeface="Jua"/>
-                <a:sym typeface="Jua"/>
+                <a:latin typeface="무궁화 고딕"/>
+                <a:ea typeface="무궁화 고딕"/>
+                <a:cs typeface="무궁화 고딕"/>
+                <a:sym typeface="무궁화 고딕"/>
               </a:rPr>
               <a:t>라이트 형제</a:t>
             </a:r>
@@ -8051,8 +8047,8 @@
         </p:nvSpPr>
         <p:spPr>
           <a:xfrm rot="0">
-            <a:off x="1135011" y="3190875"/>
-            <a:ext cx="16017978" cy="3629025"/>
+            <a:off x="1135011" y="3457575"/>
+            <a:ext cx="16017978" cy="3362325"/>
           </a:xfrm>
           <a:prstGeom prst="rect">
             <a:avLst/>
@@ -8074,10 +8070,10 @@
                 <a:solidFill>
                   <a:srgbClr val="000000"/>
                 </a:solidFill>
-                <a:latin typeface="Jua"/>
-                <a:ea typeface="Jua"/>
-                <a:cs typeface="Jua"/>
-                <a:sym typeface="Jua"/>
+                <a:latin typeface="무궁화 고딕"/>
+                <a:ea typeface="무궁화 고딕"/>
+                <a:cs typeface="무궁화 고딕"/>
+                <a:sym typeface="무궁화 고딕"/>
               </a:rPr>
               <a:t>모나리자를 그린 화가는</a:t>
             </a:r>
@@ -8093,10 +8089,10 @@
                 <a:solidFill>
                   <a:srgbClr val="000000"/>
                 </a:solidFill>
-                <a:latin typeface="Jua"/>
-                <a:ea typeface="Jua"/>
-                <a:cs typeface="Jua"/>
-                <a:sym typeface="Jua"/>
+                <a:latin typeface="무궁화 고딕"/>
+                <a:ea typeface="무궁화 고딕"/>
+                <a:cs typeface="무궁화 고딕"/>
+                <a:sym typeface="무궁화 고딕"/>
               </a:rPr>
               <a:t>누구일까요?</a:t>
             </a:r>
@@ -8193,8 +8189,8 @@
         </p:nvSpPr>
         <p:spPr>
           <a:xfrm rot="0">
-            <a:off x="2717556" y="3933825"/>
-            <a:ext cx="12852888" cy="2124075"/>
+            <a:off x="2717556" y="4219575"/>
+            <a:ext cx="12852888" cy="1838325"/>
           </a:xfrm>
           <a:prstGeom prst="rect">
             <a:avLst/>
@@ -8216,10 +8212,10 @@
                 <a:solidFill>
                   <a:srgbClr val="000000"/>
                 </a:solidFill>
-                <a:latin typeface="Jua"/>
-                <a:ea typeface="Jua"/>
-                <a:cs typeface="Jua"/>
-                <a:sym typeface="Jua"/>
+                <a:latin typeface="무궁화 고딕"/>
+                <a:ea typeface="무궁화 고딕"/>
+                <a:cs typeface="무궁화 고딕"/>
+                <a:sym typeface="무궁화 고딕"/>
               </a:rPr>
               <a:t>레오나르도 다빈치</a:t>
             </a:r>
@@ -8316,8 +8312,8 @@
         </p:nvSpPr>
         <p:spPr>
           <a:xfrm rot="0">
-            <a:off x="1135011" y="3190875"/>
-            <a:ext cx="16017978" cy="3629025"/>
+            <a:off x="1135011" y="3457575"/>
+            <a:ext cx="16017978" cy="3362325"/>
           </a:xfrm>
           <a:prstGeom prst="rect">
             <a:avLst/>
@@ -8339,10 +8335,10 @@
                 <a:solidFill>
                   <a:srgbClr val="000000"/>
                 </a:solidFill>
-                <a:latin typeface="Jua"/>
-                <a:ea typeface="Jua"/>
-                <a:cs typeface="Jua"/>
-                <a:sym typeface="Jua"/>
+                <a:latin typeface="무궁화 고딕"/>
+                <a:ea typeface="무궁화 고딕"/>
+                <a:cs typeface="무궁화 고딕"/>
+                <a:sym typeface="무궁화 고딕"/>
               </a:rPr>
               <a:t>올림픽이 처음 시작된 나라는</a:t>
             </a:r>
@@ -8358,10 +8354,10 @@
                 <a:solidFill>
                   <a:srgbClr val="000000"/>
                 </a:solidFill>
-                <a:latin typeface="Jua"/>
-                <a:ea typeface="Jua"/>
-                <a:cs typeface="Jua"/>
-                <a:sym typeface="Jua"/>
+                <a:latin typeface="무궁화 고딕"/>
+                <a:ea typeface="무궁화 고딕"/>
+                <a:cs typeface="무궁화 고딕"/>
+                <a:sym typeface="무궁화 고딕"/>
               </a:rPr>
               <a:t>어디일까요?</a:t>
             </a:r>
@@ -8458,8 +8454,8 @@
         </p:nvSpPr>
         <p:spPr>
           <a:xfrm rot="0">
-            <a:off x="2717556" y="3933825"/>
-            <a:ext cx="12852888" cy="2124075"/>
+            <a:off x="2717556" y="4219575"/>
+            <a:ext cx="12852888" cy="1838325"/>
           </a:xfrm>
           <a:prstGeom prst="rect">
             <a:avLst/>
@@ -8481,10 +8477,10 @@
                 <a:solidFill>
                   <a:srgbClr val="000000"/>
                 </a:solidFill>
-                <a:latin typeface="Jua"/>
-                <a:ea typeface="Jua"/>
-                <a:cs typeface="Jua"/>
-                <a:sym typeface="Jua"/>
+                <a:latin typeface="무궁화 고딕"/>
+                <a:ea typeface="무궁화 고딕"/>
+                <a:cs typeface="무궁화 고딕"/>
+                <a:sym typeface="무궁화 고딕"/>
               </a:rPr>
               <a:t>그리스</a:t>
             </a:r>
@@ -8556,8 +8552,8 @@
         </p:nvSpPr>
         <p:spPr>
           <a:xfrm rot="0">
-            <a:off x="4421807" y="3895725"/>
-            <a:ext cx="9444385" cy="2200275"/>
+            <a:off x="4421807" y="4181475"/>
+            <a:ext cx="9444385" cy="1914525"/>
           </a:xfrm>
           <a:prstGeom prst="rect">
             <a:avLst/>
@@ -8579,10 +8575,10 @@
                 <a:solidFill>
                   <a:srgbClr val="000000"/>
                 </a:solidFill>
-                <a:latin typeface="Jua"/>
-                <a:ea typeface="Jua"/>
-                <a:cs typeface="Jua"/>
-                <a:sym typeface="Jua"/>
+                <a:latin typeface="무궁화 고딕"/>
+                <a:ea typeface="무궁화 고딕"/>
+                <a:cs typeface="무궁화 고딕"/>
+                <a:sym typeface="무궁화 고딕"/>
               </a:rPr>
               <a:t>감사합니다!</a:t>
             </a:r>
@@ -8729,8 +8725,8 @@
         </p:nvSpPr>
         <p:spPr>
           <a:xfrm rot="0">
-            <a:off x="1135011" y="4029075"/>
-            <a:ext cx="16017978" cy="1952625"/>
+            <a:off x="1135011" y="4333875"/>
+            <a:ext cx="16017978" cy="1609725"/>
           </a:xfrm>
           <a:prstGeom prst="rect">
             <a:avLst/>
@@ -8744,18 +8740,18 @@
           <a:p>
             <a:pPr algn="ctr">
               <a:lnSpc>
-                <a:spcPts val="13200"/>
+                <a:spcPts val="12600"/>
               </a:lnSpc>
             </a:pPr>
             <a:r>
-              <a:rPr lang="en-US" sz="11000">
+              <a:rPr lang="en-US" sz="10500">
                 <a:solidFill>
                   <a:srgbClr val="000000"/>
                 </a:solidFill>
-                <a:latin typeface="Jua"/>
-                <a:ea typeface="Jua"/>
-                <a:cs typeface="Jua"/>
-                <a:sym typeface="Jua"/>
+                <a:latin typeface="무궁화 고딕"/>
+                <a:ea typeface="무궁화 고딕"/>
+                <a:cs typeface="무궁화 고딕"/>
+                <a:sym typeface="무궁화 고딕"/>
               </a:rPr>
               <a:t>한글을 만든 왕은 누구일까요?</a:t>
             </a:r>
@@ -8852,8 +8848,8 @@
         </p:nvSpPr>
         <p:spPr>
           <a:xfrm rot="0">
-            <a:off x="2717556" y="3933825"/>
-            <a:ext cx="12852888" cy="2124075"/>
+            <a:off x="2717556" y="4219575"/>
+            <a:ext cx="12852888" cy="1838325"/>
           </a:xfrm>
           <a:prstGeom prst="rect">
             <a:avLst/>
@@ -8875,10 +8871,10 @@
                 <a:solidFill>
                   <a:srgbClr val="000000"/>
                 </a:solidFill>
-                <a:latin typeface="Jua"/>
-                <a:ea typeface="Jua"/>
-                <a:cs typeface="Jua"/>
-                <a:sym typeface="Jua"/>
+                <a:latin typeface="무궁화 고딕"/>
+                <a:ea typeface="무궁화 고딕"/>
+                <a:cs typeface="무궁화 고딕"/>
+                <a:sym typeface="무궁화 고딕"/>
               </a:rPr>
               <a:t>세종대왕</a:t>
             </a:r>
@@ -8975,8 +8971,8 @@
         </p:nvSpPr>
         <p:spPr>
           <a:xfrm rot="0">
-            <a:off x="1135011" y="3190875"/>
-            <a:ext cx="16017978" cy="3629025"/>
+            <a:off x="1135011" y="3457575"/>
+            <a:ext cx="16017978" cy="3362325"/>
           </a:xfrm>
           <a:prstGeom prst="rect">
             <a:avLst/>
@@ -8998,10 +8994,10 @@
                 <a:solidFill>
                   <a:srgbClr val="000000"/>
                 </a:solidFill>
-                <a:latin typeface="Jua"/>
-                <a:ea typeface="Jua"/>
-                <a:cs typeface="Jua"/>
-                <a:sym typeface="Jua"/>
+                <a:latin typeface="무궁화 고딕"/>
+                <a:ea typeface="무궁화 고딕"/>
+                <a:cs typeface="무궁화 고딕"/>
+                <a:sym typeface="무궁화 고딕"/>
               </a:rPr>
               <a:t>이순신 장군이 사용한</a:t>
             </a:r>
@@ -9017,10 +9013,10 @@
                 <a:solidFill>
                   <a:srgbClr val="000000"/>
                 </a:solidFill>
-                <a:latin typeface="Jua"/>
-                <a:ea typeface="Jua"/>
-                <a:cs typeface="Jua"/>
-                <a:sym typeface="Jua"/>
+                <a:latin typeface="무궁화 고딕"/>
+                <a:ea typeface="무궁화 고딕"/>
+                <a:cs typeface="무궁화 고딕"/>
+                <a:sym typeface="무궁화 고딕"/>
               </a:rPr>
               <a:t>배의 이름은 무엇일까요?</a:t>
             </a:r>
@@ -9117,8 +9113,8 @@
         </p:nvSpPr>
         <p:spPr>
           <a:xfrm rot="0">
-            <a:off x="2717556" y="3933825"/>
-            <a:ext cx="12852888" cy="2124075"/>
+            <a:off x="2717556" y="4219575"/>
+            <a:ext cx="12852888" cy="1838325"/>
           </a:xfrm>
           <a:prstGeom prst="rect">
             <a:avLst/>
@@ -9140,10 +9136,10 @@
                 <a:solidFill>
                   <a:srgbClr val="000000"/>
                 </a:solidFill>
-                <a:latin typeface="Jua"/>
-                <a:ea typeface="Jua"/>
-                <a:cs typeface="Jua"/>
-                <a:sym typeface="Jua"/>
+                <a:latin typeface="무궁화 고딕"/>
+                <a:ea typeface="무궁화 고딕"/>
+                <a:cs typeface="무궁화 고딕"/>
+                <a:sym typeface="무궁화 고딕"/>
               </a:rPr>
               <a:t>거북선</a:t>
             </a:r>
@@ -9240,8 +9236,8 @@
         </p:nvSpPr>
         <p:spPr>
           <a:xfrm rot="0">
-            <a:off x="1135011" y="3333750"/>
-            <a:ext cx="16017978" cy="3371850"/>
+            <a:off x="1135011" y="3571875"/>
+            <a:ext cx="16017978" cy="3133725"/>
           </a:xfrm>
           <a:prstGeom prst="rect">
             <a:avLst/>
@@ -9263,10 +9259,10 @@
                 <a:solidFill>
                   <a:srgbClr val="000000"/>
                 </a:solidFill>
-                <a:latin typeface="Jua"/>
-                <a:ea typeface="Jua"/>
-                <a:cs typeface="Jua"/>
-                <a:sym typeface="Jua"/>
+                <a:latin typeface="무궁화 고딕"/>
+                <a:ea typeface="무궁화 고딕"/>
+                <a:cs typeface="무궁화 고딕"/>
+                <a:sym typeface="무궁화 고딕"/>
               </a:rPr>
               <a:t>고조선을 세운 사람은</a:t>
             </a:r>
@@ -9282,10 +9278,10 @@
                 <a:solidFill>
                   <a:srgbClr val="000000"/>
                 </a:solidFill>
-                <a:latin typeface="Jua"/>
-                <a:ea typeface="Jua"/>
-                <a:cs typeface="Jua"/>
-                <a:sym typeface="Jua"/>
+                <a:latin typeface="무궁화 고딕"/>
+                <a:ea typeface="무궁화 고딕"/>
+                <a:cs typeface="무궁화 고딕"/>
+                <a:sym typeface="무궁화 고딕"/>
               </a:rPr>
               <a:t>누구일까요?</a:t>
             </a:r>

</xml_diff>